<commit_message>
fix: resolve impact analysis format in prompt and robustly parse store cards in dashboard
</commit_message>
<xml_diff>
--- a/report/2026_09_02_competitive_report_no_limit.pptx
+++ b/report/2026_09_02_competitive_report_no_limit.pptx
@@ -6429,23 +6429,112 @@
               </a:defRPr>
             </a:pPr>
             <a:r>
-              <a:t>今回の競合動向は、いかりスーパーマーケットの経営戦略において、価格競争、品質・サービス競争、そしてデジタルチャネルの強化という多角的な視点での対応が求められることを示唆しています。</a:t>
-            </a:r>
-            <a:br/>
-            <a:r>
-              <a:t>まず、オーケーやサンディといったディスカウントスーパーの積極的な新規出店は、関西エリア全体で価格志向の顧客層の選択肢を大きく広げ、いかりスーパーが強みとする高品質・高価格帯の市場においても、価格に対する顧客の意識を高める可能性があります。特に、いかり高槻店、王子店、芦屋店、御影店、宝塚店といった店舗の周辺に低価格帯の競合が出店することで、日常使いの品目において価格を比較する顧客が増加し、客数の減少につながるリスクがあります。いかりスーパーとしては、明確なブランド価値（高品質な商品、希少性の高い食材、専門性の高いサービス、快適な買い物体験など）を改めて顧客に訴求し、価格以外の価値で差別化を図ることが重要です。特に、デリや惣菜の品揃え強化、パーソナルな接客、地域に根差したイベントの開催などが有効な戦略となり得ます。</a:t>
-            </a:r>
-            <a:br/>
-            <a:r>
-              <a:t>阪急オアシスや関西スーパーのリニューアルやネットスーパーの開業は、既存の食品スーパーが多様化する顧客ニーズに対応しようとする動きとして注目されます。阪急オアシスの「マルシェ」型店舗への転換は、品質・専門性へのこだわりを強める方向であり、いかりスーパーが競合する客層と重なる可能性があります。いかりスーパーとしては、より一層、商品選定の厳格化、プライベートブランドの強化、そして店舗体験の向上（例えば、商品知識の豊富なスタッフによる提案、試食コーナーの充実など）を通じて、他社を凌駕する「食の専門性」を確立することが求められます。関西スーパーのネットスーパーは、利便性を求める顧客層への新たなアプローチであり、いかりスーパーもオンラインでの顧客接点を強化し、高品質な商品を自宅に届けるサービスを充実させることで、顧客の多様な購買行動に対応する必要があります。</a:t>
-            </a:r>
-            <a:br/>
-            <a:r>
-              <a:t>複合商業施設「ミルタ」の開業は、具体的なスーパーマーケットの出店は未定であるものの、周辺地域の商業環境全体を活性化させ、新たな顧客流入を生み出す可能性があります。いかりスーパーとしては、これらの新たな集客スポットから自店舗への顧客誘導を促すためのマーケティング戦略や、共存共栄を図るための連携も検討する余地があるかもしれません。</a:t>
-            </a:r>
-            <a:br/>
-            <a:r>
-              <a:t>総じて、関西エリアのスーパーマーケット市場は、ディスカウント店の攻勢と既存店の業態転換・デジタル化推進により、競争環境がますます複雑化しています。いかりスーパーは、自社のブランドアイデンティティを再確認し、高品質戦略を堅持しつつ、顧客体験価値の最大化、地域密着型のサービス強化、そしてオンラインとオフラインを融合した購買体験の提供に注力することで、市場の変化に対応し、持続的な成長を実現していく必要があります。</a:t>
+              <a:t>1. いかり高槻店、王子店、芦屋店、御影店、宝塚店</a:t>
+            </a:r>
+          </a:p>
+          <a:p>
+            <a:pPr>
+              <a:spcAft>
+                <a:spcPts val="1200"/>
+              </a:spcAft>
+              <a:defRPr sz="1350">
+                <a:solidFill>
+                  <a:srgbClr val="1E1E1E"/>
+                </a:solidFill>
+              </a:defRPr>
+            </a:pPr>
+            <a:r>
+              <a:t>*   オーケー（高槻赤大路店、長吉店）やサンディ（吹田五月が丘店、都島北通店、芦屋店、御影店、宝塚南店）などディスカウントスーパーの集中出店により、日常使いの品目において価格比較や顧客流出のリスクが生じます。</a:t>
+            </a:r>
+          </a:p>
+          <a:p>
+            <a:pPr>
+              <a:spcAft>
+                <a:spcPts val="1200"/>
+              </a:spcAft>
+              <a:defRPr sz="1350">
+                <a:solidFill>
+                  <a:srgbClr val="1E1E1E"/>
+                </a:solidFill>
+              </a:defRPr>
+            </a:pPr>
+            <a:r>
+              <a:t>*   対策として、高品質な生鮮食材、希少なこだわり商品、デリ・惣菜の強化、上質な対面接客によるブランド価値の再訴求が重要です。</a:t>
+            </a:r>
+          </a:p>
+          <a:p>
+            <a:pPr>
+              <a:spcAft>
+                <a:spcPts val="1200"/>
+              </a:spcAft>
+              <a:defRPr sz="1350">
+                <a:solidFill>
+                  <a:srgbClr val="1E1E1E"/>
+                </a:solidFill>
+              </a:defRPr>
+            </a:pPr>
+            <a:r>
+              <a:t>2. いかり宝塚店、阪急逆瀬川店、箕面店、御影店、六甲店</a:t>
+            </a:r>
+          </a:p>
+          <a:p>
+            <a:pPr>
+              <a:spcAft>
+                <a:spcPts val="1200"/>
+              </a:spcAft>
+              <a:defRPr sz="1350">
+                <a:solidFill>
+                  <a:srgbClr val="1E1E1E"/>
+                </a:solidFill>
+              </a:defRPr>
+            </a:pPr>
+            <a:r>
+              <a:t>*   阪急オアシス日生中央店（マルシェ型への価値訴求リニューアル）や関西スーパー（瑞光店のネットスーパー開始、日下店リニューアル等）により、品質・専門性や利便性での競合が強まります。</a:t>
+            </a:r>
+          </a:p>
+          <a:p>
+            <a:pPr>
+              <a:spcAft>
+                <a:spcPts val="1200"/>
+              </a:spcAft>
+              <a:defRPr sz="1350">
+                <a:solidFill>
+                  <a:srgbClr val="1E1E1E"/>
+                </a:solidFill>
+              </a:defRPr>
+            </a:pPr>
+            <a:r>
+              <a:t>*   商品選定の厳格化、PB（プライベートブランド）の拡充、およびオンライン接点の強化が求められます。</a:t>
+            </a:r>
+          </a:p>
+          <a:p>
+            <a:pPr>
+              <a:spcAft>
+                <a:spcPts val="1200"/>
+              </a:spcAft>
+              <a:defRPr sz="1350">
+                <a:solidFill>
+                  <a:srgbClr val="1E1E1E"/>
+                </a:solidFill>
+              </a:defRPr>
+            </a:pPr>
+            <a:r>
+              <a:t>3. いかり神戸三宮店、御影店、六甲店、岡本店</a:t>
+            </a:r>
+          </a:p>
+          <a:p>
+            <a:pPr>
+              <a:spcAft>
+                <a:spcPts val="1200"/>
+              </a:spcAft>
+              <a:defRPr sz="1350">
+                <a:solidFill>
+                  <a:srgbClr val="1E1E1E"/>
+                </a:solidFill>
+              </a:defRPr>
+            </a:pPr>
+            <a:r>
+              <a:t>*   垂水駅前の複合再開発施設「ミルタ（プラウドタワー神戸垂水）」開業などによる商業環境の変化を注視し、新たな集客スポットからの自店舗誘導マーケティングや差別化戦略を推進する必要があります。</a:t>
             </a:r>
           </a:p>
         </p:txBody>

</xml_diff>